<commit_message>
Explain residual oscillation after filtering the positive step
Slide 19 now states that 3 to 11 % of the 2.27 Hz amplitude remain
between 3 and 7 s. The measured envelope still rises until about 4 s,
so the exponentially decaying model matches it only approximately;
for the negative step less than 1 % remains. Speaker notes add the
per-second amplitudes and the sensitivity to the analysis start.

Co-Authored-By: Claude Opus 5.5 <noreply@anthropic.com>
</commit_message>
<xml_diff>
--- a/docs/praesentation/Ergebnisse_Matrix_Pencil_Arbeitsfassung.pptx
+++ b/docs/praesentation/Ergebnisse_Matrix_Pencil_Arbeitsfassung.pptx
@@ -127,12 +127,12 @@
   <p:extLst>
     <p:ext uri="{521415D9-36F7-43E2-AB2F-B90AF26B5E84}">
       <p14:sectionLst xmlns:p14="http://schemas.microsoft.com/office/powerpoint/2010/main">
-        <p14:section name="Einstieg" id="{c12bd02a-3a04-60ff-e95c-52716910bf9f}">
+        <p14:section name="Einstieg" id="{8fde3fe1-81a3-e996-7a1d-3fafadf6570b}">
           <p14:sldIdLst>
             <p14:sldId id="256"/>
           </p14:sldIdLst>
         </p14:section>
-        <p14:section name="Hintergrund" id="{a9f2c405-f509-5b73-ffca-ae0b8354feff}">
+        <p14:section name="Hintergrund" id="{2ff3b851-370b-7bf5-595e-10d471d7bd19}">
           <p14:sldIdLst>
             <p14:sldId id="257"/>
             <p14:sldId id="258"/>
@@ -140,7 +140,7 @@
             <p14:sldId id="260"/>
           </p14:sldIdLst>
         </p14:section>
-        <p14:section name="Methode" id="{40581a1d-6993-2b38-80eb-398fac4e3352}">
+        <p14:section name="Methode" id="{05e2c5e8-274e-028b-9a2c-30b8cb076fea}">
           <p14:sldIdLst>
             <p14:sldId id="261"/>
             <p14:sldId id="262"/>
@@ -150,7 +150,7 @@
             <p14:sldId id="266"/>
           </p14:sldIdLst>
         </p14:section>
-        <p14:section name="Prüfstufen 1 bis 3" id="{04d5960e-a4a0-2c50-a657-1c27f21f9939}">
+        <p14:section name="Prüfstufen 1 bis 3" id="{20f4cf55-de93-8531-0a1a-d4edee4f43c9}">
           <p14:sldIdLst>
             <p14:sldId id="267"/>
             <p14:sldId id="268"/>
@@ -159,19 +159,19 @@
             <p14:sldId id="271"/>
           </p14:sldIdLst>
         </p14:section>
-        <p14:section name="Prüfstufe 4: eigene Messungen" id="{34c56f2a-6490-4f53-77fd-7b4216bce027}">
+        <p14:section name="Prüfstufe 4: eigene Messungen" id="{d09c4c35-8783-08c2-7574-83b0a3a48fd7}">
           <p14:sldIdLst>
             <p14:sldId id="272"/>
             <p14:sldId id="273"/>
             <p14:sldId id="274"/>
           </p14:sldIdLst>
         </p14:section>
-        <p14:section name="Fazit" id="{a7b5af04-c073-d1db-5723-97c06e22363e}">
+        <p14:section name="Fazit" id="{2af36fea-2356-db6f-149f-0655087ae88e}">
           <p14:sldIdLst>
             <p14:sldId id="275"/>
           </p14:sldIdLst>
         </p14:section>
-        <p14:section name="Anhang" id="{1abc53d1-b7af-c62b-3919-89033edb0204}">
+        <p14:section name="Anhang" id="{9506262b-c4f8-e066-d5c2-b76673cc6518}">
           <p14:sldIdLst>
             <p14:sldId id="276"/>
           </p14:sldIdLst>
@@ -1500,7 +1500,12 @@
               <a:rPr lang="en-US" dirty="0"/>
               <a:t>Auch hier ist die Messung blau und die Filterausgabe orange, links der gesamte Verlauf, rechts der Abschnitt von vier bis sieben Sekunden.
 Beim positiven Frequenzsprung bricht P pos kurz nach einer Sekunde stark ein und pendelt danach. Abgezogen werden zwei Schwingungsanteile: der dominante bei 2,268 Hertz und ein zweiter bei 2,480 Hertz, der deutlich schneller abklingt. Die orange Kurve ist also die Messung minus die Summe beider Anteile.
-Im Ausschnitt bleiben kleine Restwellen sichtbar, die Bandenergie im Zielband sinkt aber um 99,87 Prozent. Vor einer Sekunde bleiben alle Werte unverändert.
+Vor einer Sekunde bleiben alle Werte unverändert. Im Ausschnitt rechts sieht man aber, anders als beim negativen Sprung, noch kleine Restwellen in der orangen Kurve. Warum?
+Das Modell beschreibt jede Schwingung als Amplitude mal e hoch Sigma t. Ihre Hüllkurve klingt also gleichmäßig exponentiell ab. Beim negativen Sprung verhält sich die Messung genau so: Sekunde für Sekunde weicht die gemessene 2,27-Hertz-Amplitude um weniger als ein Prozent vom Modell ab, und nach dem Abzug bleibt weniger als ein Prozent übrig.
+Beim positiven Sprung nicht. Zwischen zwei und vier Sekunden steigt die gemessene Amplitude zunächst noch an, von etwa 15 500 auf 18 200 Dateieinheiten, und fällt erst danach. Eine einzelne exponentiell abklingende Schwingung kann das nicht nachbilden. Das Modell hilft sich mit dem zweiten, schnell abklingenden Anteil bei 2,48 Hertz, trifft die Amplitude aber nur ungefähr. Zwischen drei und sieben Sekunden bleiben deshalb je nach Sekunde 3 bis 11 Prozent der Amplitude stehen. Das ist die sichtbare Restwelle.
+Die 99,87 Prozent weniger Bandenergie widersprechen dem nicht. Die Energie wächst mit dem Quadrat der Amplitude: Wenige Prozent Restamplitude sind nur Promille der Energie.
+Warum die Hüllkurve nicht exponentiell verläuft, ist in den Daten nicht nachgewiesen. Ein möglicher Grund ist der tiefe Einbruch nach dem positiven Sprung: Solange die Anlage diesen großen Ausschlag ausregelt, verhält sie sich vermutlich nicht wie ein einfaches lineares System.
+Beginnt man die Analyse bei 1,5 statt bei einer Sekunde, bleiben nur 1 bis 2 Prozent übrig. Dafür ändert sich die Zerlegung: drei Anteile im Band, und die Abklingrate der Hauptschwingung wird minus 0,177 statt minus 0,107 pro Sekunde. Wir bleiben bei einer Sekunde, weil der FNN-Hinweis die Zeit ab Beginn des Ereignisses zählt. Wie bei Mexiko gilt: Einen Parameter so lange zu verschieben, bis das Bild schöner aussieht, wäre keine bessere Bereinigung.
 Das Gesamtmodell passt mit weniger als einem Prozent Fehler. Daraus folgt aber noch nicht, dass beide Anteile eindeutig reale Vorgänge beschreiben. Wie bei Mexiko gesehen, bestätigt ein kleiner Fehler allein keine physikalisch eindeutige Zerlegung.</a:t>
             </a:r>
             <a:endParaRPr lang="en-US" dirty="0"/>
@@ -11944,8 +11949,8 @@
         </p:blipFill>
         <p:spPr>
           <a:xfrm>
-            <a:off x="1524000" y="1879600"/>
-            <a:ext cx="9144000" cy="3295650"/>
+            <a:off x="2286000" y="1841500"/>
+            <a:ext cx="7620000" cy="2743200"/>
           </a:xfrm>
           <a:prstGeom prst="rect">
             <a:avLst/>
@@ -11960,12 +11965,12 @@
         </p:nvSpPr>
         <p:spPr>
           <a:xfrm>
-            <a:off x="1524000" y="1879600"/>
-            <a:ext cx="9144000" cy="3295650"/>
+            <a:off x="2286000" y="1841500"/>
+            <a:ext cx="7620000" cy="2743200"/>
           </a:xfrm>
           <a:prstGeom prst="roundRect">
             <a:avLst>
-              <a:gd name="adj" fmla="val 3052"/>
+              <a:gd name="adj" fmla="val 3667"/>
             </a:avLst>
           </a:prstGeom>
           <a:ln w="9525">
@@ -11984,8 +11989,8 @@
         </p:nvSpPr>
         <p:spPr>
           <a:xfrm>
-            <a:off x="812800" y="5353050"/>
-            <a:ext cx="3314700" cy="266700"/>
+            <a:off x="812800" y="4724400"/>
+            <a:ext cx="2514600" cy="266700"/>
           </a:xfrm>
           <a:prstGeom prst="rect">
             <a:avLst/>
@@ -12026,8 +12031,8 @@
         </p:nvSpPr>
         <p:spPr>
           <a:xfrm>
-            <a:off x="812800" y="5645150"/>
-            <a:ext cx="3314700" cy="228600"/>
+            <a:off x="812800" y="5016500"/>
+            <a:ext cx="2514600" cy="444500"/>
           </a:xfrm>
           <a:prstGeom prst="rect">
             <a:avLst/>
@@ -12068,8 +12073,8 @@
         </p:nvSpPr>
         <p:spPr>
           <a:xfrm>
-            <a:off x="4436533" y="5353050"/>
-            <a:ext cx="3314700" cy="266700"/>
+            <a:off x="3517900" y="4724400"/>
+            <a:ext cx="2514600" cy="266700"/>
           </a:xfrm>
           <a:prstGeom prst="rect">
             <a:avLst/>
@@ -12110,8 +12115,8 @@
         </p:nvSpPr>
         <p:spPr>
           <a:xfrm>
-            <a:off x="4436533" y="5645150"/>
-            <a:ext cx="3314700" cy="228600"/>
+            <a:off x="3517900" y="5016500"/>
+            <a:ext cx="2514600" cy="444500"/>
           </a:xfrm>
           <a:prstGeom prst="rect">
             <a:avLst/>
@@ -12152,8 +12157,8 @@
         </p:nvSpPr>
         <p:spPr>
           <a:xfrm>
-            <a:off x="8060267" y="5353050"/>
-            <a:ext cx="3314700" cy="266700"/>
+            <a:off x="6223000" y="4724400"/>
+            <a:ext cx="2514600" cy="266700"/>
           </a:xfrm>
           <a:prstGeom prst="rect">
             <a:avLst/>
@@ -12194,8 +12199,8 @@
         </p:nvSpPr>
         <p:spPr>
           <a:xfrm>
-            <a:off x="8060267" y="5645150"/>
-            <a:ext cx="3314700" cy="228600"/>
+            <a:off x="6223000" y="5016500"/>
+            <a:ext cx="2514600" cy="444500"/>
           </a:xfrm>
           <a:prstGeom prst="rect">
             <a:avLst/>
@@ -12222,9 +12227,152 @@
                 <a:ea typeface="Calibri" pitchFamily="34" charset="-122"/>
                 <a:cs typeface="Calibri" pitchFamily="34" charset="-120"/>
               </a:rPr>
-              <a:t>Bandenergie 1,76–2,64 Hz, 4 bis 7 s</a:t>
+              <a:t>Bandenergie 1,76–2,64 Hz, 4 bis 7 s</a:t>
             </a:r>
             <a:endParaRPr lang="en-US" sz="1200" dirty="0"/>
+          </a:p>
+        </p:txBody>
+      </p:sp>
+      <p:sp>
+        <p:nvSpPr>
+          <p:cNvPr id="14" name="Text 10"/>
+          <p:cNvSpPr txBox="1"/>
+          <p:nvPr/>
+        </p:nvSpPr>
+        <p:spPr>
+          <a:xfrm>
+            <a:off x="8928100" y="4724400"/>
+            <a:ext cx="2514600" cy="266700"/>
+          </a:xfrm>
+          <a:prstGeom prst="rect">
+            <a:avLst/>
+          </a:prstGeom>
+          <a:noFill/>
+          <a:ln/>
+        </p:spPr>
+        <p:txBody>
+          <a:bodyPr wrap="square" lIns="0" tIns="0" rIns="0" bIns="0" rtlCol="0" anchor="t"/>
+          <a:lstStyle/>
+          <a:p>
+            <a:pPr indent="0" marL="0">
+              <a:lnSpc>
+                <a:spcPct val="115000"/>
+              </a:lnSpc>
+              <a:buNone/>
+            </a:pPr>
+            <a:r>
+              <a:rPr lang="en-US" sz="1500" b="1" dirty="0">
+                <a:solidFill>
+                  <a:srgbClr val="B5491B"/>
+                </a:solidFill>
+                <a:latin typeface="Calibri" pitchFamily="34" charset="0"/>
+                <a:ea typeface="Calibri" pitchFamily="34" charset="-122"/>
+                <a:cs typeface="Calibri" pitchFamily="34" charset="-120"/>
+              </a:rPr>
+              <a:t>3 bis 11 % Rest</a:t>
+            </a:r>
+            <a:endParaRPr lang="en-US" sz="1500" dirty="0"/>
+          </a:p>
+        </p:txBody>
+      </p:sp>
+      <p:sp>
+        <p:nvSpPr>
+          <p:cNvPr id="15" name="Text 11"/>
+          <p:cNvSpPr txBox="1"/>
+          <p:nvPr/>
+        </p:nvSpPr>
+        <p:spPr>
+          <a:xfrm>
+            <a:off x="8928100" y="5016500"/>
+            <a:ext cx="2514600" cy="444500"/>
+          </a:xfrm>
+          <a:prstGeom prst="rect">
+            <a:avLst/>
+          </a:prstGeom>
+          <a:noFill/>
+          <a:ln/>
+        </p:spPr>
+        <p:txBody>
+          <a:bodyPr wrap="square" lIns="0" tIns="0" rIns="0" bIns="0" rtlCol="0" anchor="t"/>
+          <a:lstStyle/>
+          <a:p>
+            <a:pPr indent="0" marL="0">
+              <a:lnSpc>
+                <a:spcPct val="115000"/>
+              </a:lnSpc>
+              <a:buNone/>
+            </a:pPr>
+            <a:r>
+              <a:rPr lang="en-US" sz="1200" dirty="0">
+                <a:solidFill>
+                  <a:srgbClr val="44505E"/>
+                </a:solidFill>
+                <a:latin typeface="Calibri" pitchFamily="34" charset="0"/>
+                <a:ea typeface="Calibri" pitchFamily="34" charset="-122"/>
+                <a:cs typeface="Calibri" pitchFamily="34" charset="-120"/>
+              </a:rPr>
+              <a:t>der 2,27-Hz-Amplitude, je Sekunde von 3 bis 7 s</a:t>
+            </a:r>
+            <a:endParaRPr lang="en-US" sz="1200" dirty="0"/>
+          </a:p>
+        </p:txBody>
+      </p:sp>
+      <p:sp>
+        <p:nvSpPr>
+          <p:cNvPr id="16" name="Text 12"/>
+          <p:cNvSpPr txBox="1"/>
+          <p:nvPr/>
+        </p:nvSpPr>
+        <p:spPr>
+          <a:xfrm>
+            <a:off x="812800" y="5575300"/>
+            <a:ext cx="10566400" cy="571500"/>
+          </a:xfrm>
+          <a:prstGeom prst="rect">
+            <a:avLst/>
+          </a:prstGeom>
+          <a:noFill/>
+          <a:ln/>
+        </p:spPr>
+        <p:txBody>
+          <a:bodyPr wrap="square" lIns="0" tIns="0" rIns="0" bIns="0" rtlCol="0" anchor="t"/>
+          <a:lstStyle/>
+          <a:p>
+            <a:pPr indent="0" marL="0">
+              <a:lnSpc>
+                <a:spcPct val="115000"/>
+              </a:lnSpc>
+              <a:buNone/>
+            </a:pPr>
+            <a:r>
+              <a:rPr lang="en-US" sz="1300" b="1" dirty="0">
+                <a:solidFill>
+                  <a:srgbClr val="14202E"/>
+                </a:solidFill>
+                <a:latin typeface="Calibri" pitchFamily="34" charset="0"/>
+                <a:ea typeface="Calibri" pitchFamily="34" charset="-122"/>
+                <a:cs typeface="Calibri" pitchFamily="34" charset="-120"/>
+              </a:rPr>
+              <a:t>Warum Restwellen bleiben: </a:t>
+            </a:r>
+            <a:pPr indent="0" marL="0">
+              <a:lnSpc>
+                <a:spcPct val="115000"/>
+              </a:lnSpc>
+              <a:buNone/>
+            </a:pPr>
+            <a:r>
+              <a:rPr lang="en-US" sz="1300" dirty="0">
+                <a:solidFill>
+                  <a:srgbClr val="44505E"/>
+                </a:solidFill>
+                <a:latin typeface="Calibri" pitchFamily="34" charset="0"/>
+                <a:ea typeface="Calibri" pitchFamily="34" charset="-122"/>
+                <a:cs typeface="Calibri" pitchFamily="34" charset="-120"/>
+              </a:rPr>
+              <a:t>Die gemessene Amplitude steigt bis etwa 4 s noch an und fällt erst dann. Das Modell kennt nur exponentielles Abklingen und trifft sie daher nur ungefähr. Beim negativen Sprung bleibt weniger als 1 %.</a:t>
+            </a:r>
+            <a:endParaRPr lang="en-US" sz="1300" dirty="0"/>
           </a:p>
         </p:txBody>
       </p:sp>

</xml_diff>

<commit_message>
Correct reference value of Delta P in slide 3 speaker notes
The FNN guideline (5.5.5.8.3, Bild 11) measures Delta P against the
stationary initial power before the step, not the new final value.
Notes now also explain the extrema S1 to S3 used for AV21 and AV32.

Co-Authored-By: Claude Opus 5.5 <noreply@anthropic.com>
</commit_message>
<xml_diff>
--- a/docs/praesentation/Ergebnisse_Matrix_Pencil_Arbeitsfassung.pptx
+++ b/docs/praesentation/Ergebnisse_Matrix_Pencil_Arbeitsfassung.pptx
@@ -127,12 +127,12 @@
   <p:extLst>
     <p:ext uri="{521415D9-36F7-43E2-AB2F-B90AF26B5E84}">
       <p14:sectionLst xmlns:p14="http://schemas.microsoft.com/office/powerpoint/2010/main">
-        <p14:section name="Einstieg" id="{8fde3fe1-81a3-e996-7a1d-3fafadf6570b}">
+        <p14:section name="Einstieg" id="{e49d9b48-363c-7218-a148-cf73941b1d29}">
           <p14:sldIdLst>
             <p14:sldId id="256"/>
           </p14:sldIdLst>
         </p14:section>
-        <p14:section name="Hintergrund" id="{2ff3b851-370b-7bf5-595e-10d471d7bd19}">
+        <p14:section name="Hintergrund" id="{ee707f9b-adfa-aacd-c9b9-67fef5d63118}">
           <p14:sldIdLst>
             <p14:sldId id="257"/>
             <p14:sldId id="258"/>
@@ -140,7 +140,7 @@
             <p14:sldId id="260"/>
           </p14:sldIdLst>
         </p14:section>
-        <p14:section name="Methode" id="{05e2c5e8-274e-028b-9a2c-30b8cb076fea}">
+        <p14:section name="Methode" id="{8f635698-6eee-b6e2-ca55-18ab3c510667}">
           <p14:sldIdLst>
             <p14:sldId id="261"/>
             <p14:sldId id="262"/>
@@ -150,7 +150,7 @@
             <p14:sldId id="266"/>
           </p14:sldIdLst>
         </p14:section>
-        <p14:section name="Prüfstufen 1 bis 3" id="{20f4cf55-de93-8531-0a1a-d4edee4f43c9}">
+        <p14:section name="Prüfstufen 1 bis 3" id="{c26afb07-b3be-8cba-b016-b89514040724}">
           <p14:sldIdLst>
             <p14:sldId id="267"/>
             <p14:sldId id="268"/>
@@ -159,19 +159,19 @@
             <p14:sldId id="271"/>
           </p14:sldIdLst>
         </p14:section>
-        <p14:section name="Prüfstufe 4: eigene Messungen" id="{d09c4c35-8783-08c2-7574-83b0a3a48fd7}">
+        <p14:section name="Prüfstufe 4: eigene Messungen" id="{70bd228a-ba86-995a-63dd-03594ef9b66c}">
           <p14:sldIdLst>
             <p14:sldId id="272"/>
             <p14:sldId id="273"/>
             <p14:sldId id="274"/>
           </p14:sldIdLst>
         </p14:section>
-        <p14:section name="Fazit" id="{2af36fea-2356-db6f-149f-0655087ae88e}">
+        <p14:section name="Fazit" id="{7a4a7758-1e07-b9c5-e779-e7f3c002c9e9}">
           <p14:sldIdLst>
             <p14:sldId id="275"/>
           </p14:sldIdLst>
         </p14:section>
-        <p14:section name="Anhang" id="{9506262b-c4f8-e066-d5c2-b76673cc6518}">
+        <p14:section name="Anhang" id="{469feae7-6981-887c-86ae-b2c61a5db69a}">
           <p14:sldIdLst>
             <p14:sldId id="276"/>
           </p14:sldIdLst>
@@ -1870,7 +1870,7 @@
               <a:t>Was genau fordert der FNN-Hinweis? Drei Stellen sind für uns wichtig.
 Abschnitt 4.2.1.12: Die netzbildende Einheit muss Frequenz-Leistungspendelungen zwischen 0,05 und 10 Hertz dämpfen. Das Dämpfungsmaß darf 0,5 nicht unterschreiten. Nachzuweisen ist das bei einem SCR von mindestens 3. SCR steht für Short Circuit Ratio, auf Deutsch Kurzschlussleistungsverhältnis: das Verhältnis der Kurzschlussleistung am Netzanschlusspunkt zur Leistung der Anlage. Je größer der Wert, desto stärker ist das Netz an dieser Stelle.
 Abschnitt 5.5.5.8 beschreibt die Prüfung. Bei Messverfahren 1 springt die Frequenz um etwa 250 bis 500 Millihertz, während die Einheit 50 bis 75 Prozent ihrer maximalen Wirkleistung PEmax einspeist. Gemessen wird p1, die Mitsystem-Wirkleistung der Grundschwingung. Unsere Messung passt dazu: Die Frequenz springt von 50,0 auf 49,5 Hertz, also um 500 Millihertz.
-Ausgewertet werden die Überschwinger der Wirkleistung nach dem Sprung, gemessen gegenüber dem neuen Endwert. AV21 ist der zweite Überschwinger geteilt durch den ersten, AV32 der dritte durch den zweiten. Nach dem TR8-Hinweis, also der Bewertungsgrundlage für die Zertifizierung, muss das Dämpfungsmaß mindestens 0,45 betragen. Sind drei Extrema erkennbar, müssen beide Amplitudenverhältnisse unter 0,2 liegen. Beide Grenzen passen zusammen: Bei D gleich 0,45 schrumpft ein Überschwinger zum nächsten auf etwa 0,2.
+Ausgewertet werden die Überschwinger der Wirkleistung nach der ersten Reaktion auf den Sprung. Delta P ist dabei die Abweichung vom stationären Anfangswert, also vom Leistungswert vor dem Sprung. Delta P S1 ist der erste Überschwinger, S2 und S3 sind die folgenden Extrema mit jeweils umgekehrtem Vorzeichen. AV21 ist der zweite Überschwinger geteilt durch den ersten, AV32 der dritte durch den zweiten. Diese Verhältnisse liest man direkt an der Messkurve ab, ohne Modell. Nach dem TR8-Hinweis, also der Bewertungsgrundlage für die Zertifizierung, muss das Dämpfungsmaß mindestens 0,45 betragen. Sind drei Extrema erkennbar, müssen beide Amplitudenverhältnisse unter 0,2 liegen. Beide Grenzen passen zusammen: Bei D gleich 0,45 schrumpft ein Überschwinger zum nächsten auf etwa 0,2.
 Rechts steht die Definition des Dämpfungsmaßes. Für die 2,27-Hertz-Pendelung unserer Messung ergibt sie etwa 0,013, weit unter 0,45. Wenn diese Pendelung mechanisch bedingt ist und nicht herausgerechnet wird, bestimmt sie die Bewertung, obwohl sie nichts über die Regelung der Anlage aussagt. Ob sie tatsächlich mechanisch ist, ist in unseren Daten nicht dokumentiert; im Projekt wird eine Resonanz um 2,2 Hertz angenommen.</a:t>
             </a:r>
             <a:endParaRPr lang="en-US" dirty="0"/>

</xml_diff>